<commit_message>
fix(word/table): stop flagging consumed 'data' key as unsupported
The inline 'data' shorthand (--prop data=A,B;1,2) is consumed up-front by
TryGetValue("data") to build the grid, but the later tblPr switch loop had no
skip/case for it, so its default branch pushed 'data' into LastAddUnsupportedProps
— a spurious unsupported_property WARNING on a key that worked. Add 'data' to the
same skip-list that already excludes rows/cols/colwidths (all consumed elsewhere).
Genuine typos still warn.

Also closes the word tables example: demonstrate the 'data' shorthand (Table 7),
taking table@docx coverage to 19/19. Fixed a pre-existing breakage in tables.sh
where the PPTX section used the rejected '/presentation/slides' parent instead of
'/', so tables.pptx never rebuilt. Regenerated docx/xlsx/pptx — all open in real
Office (officeshot) and validate clean. Table test suite green (1887).
</commit_message>
<xml_diff>
--- a/examples/word/tables.pptx
+++ b/examples/word/tables.pptx
@@ -1,10 +1,14 @@
 
 <file path=ppt/presentation.xml><?xml version="1.0" encoding="utf-8"?>
-<p:presentation xmlns:p="http://schemas.openxmlformats.org/presentationml/2006/main">
+<p:presentation xmlns:r="http://schemas.openxmlformats.org/officeDocument/2006/relationships" xmlns:p="http://schemas.openxmlformats.org/presentationml/2006/main">
   <p:sldMasterIdLst>
     <p:sldMasterId xmlns:r="http://schemas.openxmlformats.org/officeDocument/2006/relationships" id="2147483648" r:id="rId1"/>
   </p:sldMasterIdLst>
-  <p:sldIdLst/>
+  <p:sldIdLst>
+    <p:sldId id="256" r:id="Rf767efc9db5349b1"/>
+    <p:sldId id="257" r:id="Rc70f4b162de34128"/>
+    <p:sldId id="258" r:id="Reca210099e0340b2"/>
+  </p:sldIdLst>
   <p:sldSz cx="12192000" cy="6858000"/>
   <p:notesSz cx="6858000" cy="9144000"/>
 </p:presentation>
@@ -298,6 +302,844 @@
     <p:sldLayoutId xmlns:r="http://schemas.openxmlformats.org/officeDocument/2006/relationships" id="2147483653" r:id="rId5"/>
   </p:sldLayoutIdLst>
 </p:sldMaster>
+</file>
+
+<file path=ppt/slides/slide1.xml><?xml version="1.0" encoding="utf-8"?>
+<p:sld xmlns:p="http://schemas.openxmlformats.org/presentationml/2006/main">
+  <p:cSld>
+    <p:bg>
+      <p:bgPr>
+        <a:solidFill xmlns:a="http://schemas.openxmlformats.org/drawingml/2006/main">
+          <a:srgbClr val="1F3864"/>
+        </a:solidFill>
+        <a:effectLst xmlns:a="http://schemas.openxmlformats.org/drawingml/2006/main"/>
+      </p:bgPr>
+    </p:bg>
+    <p:spTree>
+      <p:nvGrpSpPr>
+        <p:cNvPr id="1" name=""/>
+        <p:cNvGrpSpPr/>
+        <p:nvPr/>
+      </p:nvGrpSpPr>
+      <p:grpSpPr>
+        <a:xfrm xmlns:a="http://schemas.openxmlformats.org/drawingml/2006/main">
+          <a:off x="0" y="0"/>
+          <a:ext cx="0" cy="0"/>
+          <a:chOff x="0" y="0"/>
+          <a:chExt cx="0" cy="0"/>
+        </a:xfrm>
+      </p:grpSpPr>
+      <p:sp>
+        <p:nvSpPr>
+          <p:cNvPr id="2" name="Title"/>
+          <p:cNvSpPr/>
+          <p:nvPr/>
+        </p:nvSpPr>
+        <p:spPr>
+          <a:xfrm xmlns:a="http://schemas.openxmlformats.org/drawingml/2006/main">
+            <a:off x="1500000" y="2000000"/>
+            <a:ext cx="9192000" cy="1200000"/>
+          </a:xfrm>
+          <a:prstGeom xmlns:a="http://schemas.openxmlformats.org/drawingml/2006/main" prst="rect">
+            <a:avLst/>
+          </a:prstGeom>
+          <a:noFill xmlns:a="http://schemas.openxmlformats.org/drawingml/2006/main"/>
+        </p:spPr>
+        <p:txBody>
+          <a:bodyPr xmlns:a="http://schemas.openxmlformats.org/drawingml/2006/main" anchor="ctr"/>
+          <a:lstStyle xmlns:a="http://schemas.openxmlformats.org/drawingml/2006/main"/>
+          <a:p xmlns:a="http://schemas.openxmlformats.org/drawingml/2006/main">
+            <a:pPr algn="ctr"/>
+            <a:r>
+              <a:rPr lang="en-US" sz="4000" b="1" dirty="0">
+                <a:solidFill>
+                  <a:srgbClr val="FFFFFF"/>
+                </a:solidFill>
+              </a:rPr>
+              <a:t>2025 Annual Data Analysis Report</a:t>
+            </a:r>
+          </a:p>
+        </p:txBody>
+      </p:sp>
+      <p:sp>
+        <p:nvSpPr>
+          <p:cNvPr id="3" name="Subtitle"/>
+          <p:cNvSpPr/>
+          <p:nvPr/>
+        </p:nvSpPr>
+        <p:spPr>
+          <a:xfrm xmlns:a="http://schemas.openxmlformats.org/drawingml/2006/main">
+            <a:off x="2500000" y="3500000"/>
+            <a:ext cx="7192000" cy="800000"/>
+          </a:xfrm>
+          <a:prstGeom xmlns:a="http://schemas.openxmlformats.org/drawingml/2006/main" prst="rect">
+            <a:avLst/>
+          </a:prstGeom>
+          <a:noFill xmlns:a="http://schemas.openxmlformats.org/drawingml/2006/main"/>
+        </p:spPr>
+        <p:txBody>
+          <a:bodyPr xmlns:a="http://schemas.openxmlformats.org/drawingml/2006/main" anchor="ctr"/>
+          <a:lstStyle xmlns:a="http://schemas.openxmlformats.org/drawingml/2006/main"/>
+          <a:p xmlns:a="http://schemas.openxmlformats.org/drawingml/2006/main">
+            <a:pPr algn="ctr"/>
+            <a:r>
+              <a:rPr lang="en-US" sz="2000" dirty="0">
+                <a:solidFill>
+                  <a:srgbClr val="BDD7EE"/>
+                </a:solidFill>
+              </a:rPr>
+              <a:t>Dept Comparison | Performance Overview | Financial Summary</a:t>
+            </a:r>
+          </a:p>
+        </p:txBody>
+      </p:sp>
+    </p:spTree>
+  </p:cSld>
+</p:sld>
+</file>
+
+<file path=ppt/slides/slide2.xml><?xml version="1.0" encoding="utf-8"?>
+<p:sld xmlns:p="http://schemas.openxmlformats.org/presentationml/2006/main">
+  <p:cSld>
+    <p:spTree>
+      <p:nvGrpSpPr>
+        <p:cNvPr id="1" name=""/>
+        <p:cNvGrpSpPr/>
+        <p:nvPr/>
+      </p:nvGrpSpPr>
+      <p:grpSpPr>
+        <a:xfrm xmlns:a="http://schemas.openxmlformats.org/drawingml/2006/main">
+          <a:off x="0" y="0"/>
+          <a:ext cx="0" cy="0"/>
+          <a:chOff x="0" y="0"/>
+          <a:chExt cx="0" cy="0"/>
+        </a:xfrm>
+      </p:grpSpPr>
+      <p:sp>
+        <p:nvSpPr>
+          <p:cNvPr id="2" name="Title"/>
+          <p:cNvSpPr/>
+          <p:nvPr/>
+        </p:nvSpPr>
+        <p:spPr>
+          <a:xfrm xmlns:a="http://schemas.openxmlformats.org/drawingml/2006/main">
+            <a:off x="500000" y="200000"/>
+            <a:ext cx="11192000" cy="600000"/>
+          </a:xfrm>
+          <a:prstGeom xmlns:a="http://schemas.openxmlformats.org/drawingml/2006/main" prst="rect">
+            <a:avLst/>
+          </a:prstGeom>
+          <a:noFill xmlns:a="http://schemas.openxmlformats.org/drawingml/2006/main"/>
+        </p:spPr>
+        <p:txBody>
+          <a:bodyPr xmlns:a="http://schemas.openxmlformats.org/drawingml/2006/main"/>
+          <a:lstStyle xmlns:a="http://schemas.openxmlformats.org/drawingml/2006/main"/>
+          <a:p xmlns:a="http://schemas.openxmlformats.org/drawingml/2006/main">
+            <a:pPr algn="l"/>
+            <a:r>
+              <a:rPr lang="en-US" sz="2800" b="1" dirty="0">
+                <a:solidFill>
+                  <a:srgbClr val="1F3864"/>
+                </a:solidFill>
+              </a:rPr>
+              <a:t>Quarterly Sales by Department</a:t>
+            </a:r>
+          </a:p>
+        </p:txBody>
+      </p:sp>
+      <p:graphicFrame>
+        <p:nvGraphicFramePr>
+          <p:cNvPr id="4" name="Table"/>
+          <p:cNvGraphicFramePr>
+            <a:graphicFrameLocks xmlns:a="http://schemas.openxmlformats.org/drawingml/2006/main" noGrp="1"/>
+          </p:cNvGraphicFramePr>
+          <p:nvPr/>
+        </p:nvGraphicFramePr>
+        <p:xfrm>
+          <a:off xmlns:a="http://schemas.openxmlformats.org/drawingml/2006/main" x="500000" y="1000000"/>
+          <a:ext xmlns:a="http://schemas.openxmlformats.org/drawingml/2006/main" cx="11192000" cy="4500000"/>
+        </p:xfrm>
+        <a:graphic xmlns:a="http://schemas.openxmlformats.org/drawingml/2006/main">
+          <a:graphicData uri="http://schemas.openxmlformats.org/drawingml/2006/table">
+            <a:tbl>
+              <a:tblPr firstRow="1" bandRow="1"/>
+              <a:tblGrid>
+                <a:gridCol w="2238400"/>
+                <a:gridCol w="2238400"/>
+                <a:gridCol w="2238400"/>
+                <a:gridCol w="2238400"/>
+                <a:gridCol w="2238400"/>
+              </a:tblGrid>
+              <a:tr h="700000">
+                <a:tc>
+                  <a:txBody>
+                    <a:bodyPr/>
+                    <a:lstStyle/>
+                    <a:p>
+                      <a:pPr algn="ctr"/>
+                      <a:r>
+                        <a:rPr lang="en-US" sz="1600" b="1" dirty="0">
+                          <a:solidFill>
+                            <a:srgbClr val="FFFFFF"/>
+                          </a:solidFill>
+                        </a:rPr>
+                        <a:t>Department</a:t>
+                      </a:r>
+                    </a:p>
+                  </a:txBody>
+                  <a:tcPr>
+                    <a:solidFill>
+                      <a:srgbClr val="2E75B6"/>
+                    </a:solidFill>
+                  </a:tcPr>
+                </a:tc>
+                <a:tc>
+                  <a:txBody>
+                    <a:bodyPr/>
+                    <a:lstStyle/>
+                    <a:p>
+                      <a:pPr algn="ctr"/>
+                      <a:r>
+                        <a:rPr lang="en-US" sz="1600" b="1" dirty="0">
+                          <a:solidFill>
+                            <a:srgbClr val="FFFFFF"/>
+                          </a:solidFill>
+                        </a:rPr>
+                        <a:t>Q1</a:t>
+                      </a:r>
+                    </a:p>
+                  </a:txBody>
+                  <a:tcPr>
+                    <a:solidFill>
+                      <a:srgbClr val="2E75B6"/>
+                    </a:solidFill>
+                  </a:tcPr>
+                </a:tc>
+                <a:tc>
+                  <a:txBody>
+                    <a:bodyPr/>
+                    <a:lstStyle/>
+                    <a:p>
+                      <a:pPr algn="ctr"/>
+                      <a:r>
+                        <a:rPr lang="en-US" sz="1600" b="1" dirty="0">
+                          <a:solidFill>
+                            <a:srgbClr val="FFFFFF"/>
+                          </a:solidFill>
+                        </a:rPr>
+                        <a:t>Q2</a:t>
+                      </a:r>
+                    </a:p>
+                  </a:txBody>
+                  <a:tcPr>
+                    <a:solidFill>
+                      <a:srgbClr val="2E75B6"/>
+                    </a:solidFill>
+                  </a:tcPr>
+                </a:tc>
+                <a:tc>
+                  <a:txBody>
+                    <a:bodyPr/>
+                    <a:lstStyle/>
+                    <a:p>
+                      <a:pPr algn="ctr"/>
+                      <a:r>
+                        <a:rPr lang="en-US" sz="1600" b="1" dirty="0">
+                          <a:solidFill>
+                            <a:srgbClr val="FFFFFF"/>
+                          </a:solidFill>
+                        </a:rPr>
+                        <a:t>Q3</a:t>
+                      </a:r>
+                    </a:p>
+                  </a:txBody>
+                  <a:tcPr>
+                    <a:solidFill>
+                      <a:srgbClr val="2E75B6"/>
+                    </a:solidFill>
+                  </a:tcPr>
+                </a:tc>
+                <a:tc>
+                  <a:txBody>
+                    <a:bodyPr/>
+                    <a:lstStyle/>
+                    <a:p>
+                      <a:pPr algn="ctr"/>
+                      <a:r>
+                        <a:rPr lang="en-US" sz="1600" b="1" dirty="0">
+                          <a:solidFill>
+                            <a:srgbClr val="FFFFFF"/>
+                          </a:solidFill>
+                        </a:rPr>
+                        <a:t>Q4</a:t>
+                      </a:r>
+                    </a:p>
+                  </a:txBody>
+                  <a:tcPr>
+                    <a:solidFill>
+                      <a:srgbClr val="2E75B6"/>
+                    </a:solidFill>
+                  </a:tcPr>
+                </a:tc>
+              </a:tr>
+              <a:tr h="700000">
+                <a:tc>
+                  <a:txBody>
+                    <a:bodyPr/>
+                    <a:lstStyle/>
+                    <a:p>
+                      <a:pPr algn="ctr"/>
+                      <a:r>
+                        <a:rPr lang="en-US" sz="1400" dirty="0"/>
+                        <a:t>Engineering</a:t>
+                      </a:r>
+                    </a:p>
+                  </a:txBody>
+                  <a:tcPr>
+                    <a:solidFill>
+                      <a:srgbClr val="DEEAF6"/>
+                    </a:solidFill>
+                  </a:tcPr>
+                </a:tc>
+                <a:tc>
+                  <a:txBody>
+                    <a:bodyPr/>
+                    <a:lstStyle/>
+                    <a:p>
+                      <a:pPr algn="ctr"/>
+                      <a:r>
+                        <a:rPr lang="en-US" sz="1400" dirty="0"/>
+                        <a:t>128,000</a:t>
+                      </a:r>
+                    </a:p>
+                  </a:txBody>
+                  <a:tcPr/>
+                </a:tc>
+                <a:tc>
+                  <a:txBody>
+                    <a:bodyPr/>
+                    <a:lstStyle/>
+                    <a:p>
+                      <a:pPr algn="ctr"/>
+                      <a:r>
+                        <a:rPr lang="en-US" sz="1400" dirty="0"/>
+                        <a:t>156,000</a:t>
+                      </a:r>
+                    </a:p>
+                  </a:txBody>
+                  <a:tcPr/>
+                </a:tc>
+                <a:tc>
+                  <a:txBody>
+                    <a:bodyPr/>
+                    <a:lstStyle/>
+                    <a:p>
+                      <a:pPr algn="ctr"/>
+                      <a:r>
+                        <a:rPr lang="en-US" sz="1400" dirty="0"/>
+                        <a:t>189,000</a:t>
+                      </a:r>
+                    </a:p>
+                  </a:txBody>
+                  <a:tcPr/>
+                </a:tc>
+                <a:tc>
+                  <a:txBody>
+                    <a:bodyPr/>
+                    <a:lstStyle/>
+                    <a:p>
+                      <a:pPr algn="ctr"/>
+                      <a:r>
+                        <a:rPr lang="en-US" sz="1400" dirty="0"/>
+                        <a:t>210,000</a:t>
+                      </a:r>
+                    </a:p>
+                  </a:txBody>
+                  <a:tcPr/>
+                </a:tc>
+              </a:tr>
+              <a:tr h="700000">
+                <a:tc>
+                  <a:txBody>
+                    <a:bodyPr/>
+                    <a:lstStyle/>
+                    <a:p>
+                      <a:pPr algn="ctr"/>
+                      <a:r>
+                        <a:rPr lang="en-US" sz="1400" dirty="0"/>
+                        <a:t>Marketing</a:t>
+                      </a:r>
+                    </a:p>
+                  </a:txBody>
+                  <a:tcPr>
+                    <a:solidFill>
+                      <a:srgbClr val="DEEAF6"/>
+                    </a:solidFill>
+                  </a:tcPr>
+                </a:tc>
+                <a:tc>
+                  <a:txBody>
+                    <a:bodyPr/>
+                    <a:lstStyle/>
+                    <a:p>
+                      <a:pPr algn="ctr"/>
+                      <a:r>
+                        <a:rPr lang="en-US" sz="1400" dirty="0"/>
+                        <a:t>95,000</a:t>
+                      </a:r>
+                    </a:p>
+                  </a:txBody>
+                  <a:tcPr/>
+                </a:tc>
+                <a:tc>
+                  <a:txBody>
+                    <a:bodyPr/>
+                    <a:lstStyle/>
+                    <a:p>
+                      <a:pPr algn="ctr"/>
+                      <a:r>
+                        <a:rPr lang="en-US" sz="1400" dirty="0"/>
+                        <a:t>112,000</a:t>
+                      </a:r>
+                    </a:p>
+                  </a:txBody>
+                  <a:tcPr/>
+                </a:tc>
+                <a:tc>
+                  <a:txBody>
+                    <a:bodyPr/>
+                    <a:lstStyle/>
+                    <a:p>
+                      <a:pPr algn="ctr"/>
+                      <a:r>
+                        <a:rPr lang="en-US" sz="1400" dirty="0"/>
+                        <a:t>138,000</a:t>
+                      </a:r>
+                    </a:p>
+                  </a:txBody>
+                  <a:tcPr/>
+                </a:tc>
+                <a:tc>
+                  <a:txBody>
+                    <a:bodyPr/>
+                    <a:lstStyle/>
+                    <a:p>
+                      <a:pPr algn="ctr"/>
+                      <a:r>
+                        <a:rPr lang="en-US" sz="1400" dirty="0"/>
+                        <a:t>165,000</a:t>
+                      </a:r>
+                    </a:p>
+                  </a:txBody>
+                  <a:tcPr/>
+                </a:tc>
+              </a:tr>
+              <a:tr h="700000">
+                <a:tc>
+                  <a:txBody>
+                    <a:bodyPr/>
+                    <a:lstStyle/>
+                    <a:p>
+                      <a:pPr algn="ctr"/>
+                      <a:r>
+                        <a:rPr lang="en-US" sz="1400" dirty="0"/>
+                        <a:t>Operations</a:t>
+                      </a:r>
+                    </a:p>
+                  </a:txBody>
+                  <a:tcPr>
+                    <a:solidFill>
+                      <a:srgbClr val="DEEAF6"/>
+                    </a:solidFill>
+                  </a:tcPr>
+                </a:tc>
+                <a:tc>
+                  <a:txBody>
+                    <a:bodyPr/>
+                    <a:lstStyle/>
+                    <a:p>
+                      <a:pPr algn="ctr"/>
+                      <a:r>
+                        <a:rPr lang="en-US" sz="1400" dirty="0"/>
+                        <a:t>76,000</a:t>
+                      </a:r>
+                    </a:p>
+                  </a:txBody>
+                  <a:tcPr/>
+                </a:tc>
+                <a:tc>
+                  <a:txBody>
+                    <a:bodyPr/>
+                    <a:lstStyle/>
+                    <a:p>
+                      <a:pPr algn="ctr"/>
+                      <a:r>
+                        <a:rPr lang="en-US" sz="1400" dirty="0"/>
+                        <a:t>89,000</a:t>
+                      </a:r>
+                    </a:p>
+                  </a:txBody>
+                  <a:tcPr/>
+                </a:tc>
+                <a:tc>
+                  <a:txBody>
+                    <a:bodyPr/>
+                    <a:lstStyle/>
+                    <a:p>
+                      <a:pPr algn="ctr"/>
+                      <a:r>
+                        <a:rPr lang="en-US" sz="1400" dirty="0"/>
+                        <a:t>102,000</a:t>
+                      </a:r>
+                    </a:p>
+                  </a:txBody>
+                  <a:tcPr/>
+                </a:tc>
+                <a:tc>
+                  <a:txBody>
+                    <a:bodyPr/>
+                    <a:lstStyle/>
+                    <a:p>
+                      <a:pPr algn="ctr"/>
+                      <a:r>
+                        <a:rPr lang="en-US" sz="1400" dirty="0"/>
+                        <a:t>118,000</a:t>
+                      </a:r>
+                    </a:p>
+                  </a:txBody>
+                  <a:tcPr/>
+                </a:tc>
+              </a:tr>
+              <a:tr h="700000">
+                <a:tc>
+                  <a:txBody>
+                    <a:bodyPr/>
+                    <a:lstStyle/>
+                    <a:p>
+                      <a:pPr algn="ctr"/>
+                      <a:r>
+                        <a:rPr lang="en-US" sz="1400" dirty="0"/>
+                        <a:t>Sales</a:t>
+                      </a:r>
+                    </a:p>
+                  </a:txBody>
+                  <a:tcPr>
+                    <a:solidFill>
+                      <a:srgbClr val="DEEAF6"/>
+                    </a:solidFill>
+                  </a:tcPr>
+                </a:tc>
+                <a:tc>
+                  <a:txBody>
+                    <a:bodyPr/>
+                    <a:lstStyle/>
+                    <a:p>
+                      <a:pPr algn="ctr"/>
+                      <a:r>
+                        <a:rPr lang="en-US" sz="1400" dirty="0"/>
+                        <a:t>230,000</a:t>
+                      </a:r>
+                    </a:p>
+                  </a:txBody>
+                  <a:tcPr/>
+                </a:tc>
+                <a:tc>
+                  <a:txBody>
+                    <a:bodyPr/>
+                    <a:lstStyle/>
+                    <a:p>
+                      <a:pPr algn="ctr"/>
+                      <a:r>
+                        <a:rPr lang="en-US" sz="1400" dirty="0"/>
+                        <a:t>275,000</a:t>
+                      </a:r>
+                    </a:p>
+                  </a:txBody>
+                  <a:tcPr/>
+                </a:tc>
+                <a:tc>
+                  <a:txBody>
+                    <a:bodyPr/>
+                    <a:lstStyle/>
+                    <a:p>
+                      <a:pPr algn="ctr"/>
+                      <a:r>
+                        <a:rPr lang="en-US" sz="1400" dirty="0"/>
+                        <a:t>310,000</a:t>
+                      </a:r>
+                    </a:p>
+                  </a:txBody>
+                  <a:tcPr/>
+                </a:tc>
+                <a:tc>
+                  <a:txBody>
+                    <a:bodyPr/>
+                    <a:lstStyle/>
+                    <a:p>
+                      <a:pPr algn="ctr"/>
+                      <a:r>
+                        <a:rPr lang="en-US" sz="1400" dirty="0"/>
+                        <a:t>356,000</a:t>
+                      </a:r>
+                    </a:p>
+                  </a:txBody>
+                  <a:tcPr/>
+                </a:tc>
+              </a:tr>
+              <a:tr h="700000">
+                <a:tc>
+                  <a:txBody>
+                    <a:bodyPr/>
+                    <a:lstStyle/>
+                    <a:p>
+                      <a:pPr algn="ctr"/>
+                      <a:r>
+                        <a:rPr lang="en-US" sz="1400" dirty="0"/>
+                        <a:t>HR</a:t>
+                      </a:r>
+                    </a:p>
+                  </a:txBody>
+                  <a:tcPr>
+                    <a:solidFill>
+                      <a:srgbClr val="DEEAF6"/>
+                    </a:solidFill>
+                  </a:tcPr>
+                </a:tc>
+                <a:tc>
+                  <a:txBody>
+                    <a:bodyPr/>
+                    <a:lstStyle/>
+                    <a:p>
+                      <a:pPr algn="ctr"/>
+                      <a:r>
+                        <a:rPr lang="en-US" sz="1400" dirty="0"/>
+                        <a:t>45,000</a:t>
+                      </a:r>
+                    </a:p>
+                  </a:txBody>
+                  <a:tcPr/>
+                </a:tc>
+                <a:tc>
+                  <a:txBody>
+                    <a:bodyPr/>
+                    <a:lstStyle/>
+                    <a:p>
+                      <a:pPr algn="ctr"/>
+                      <a:r>
+                        <a:rPr lang="en-US" sz="1400" dirty="0"/>
+                        <a:t>48,000</a:t>
+                      </a:r>
+                    </a:p>
+                  </a:txBody>
+                  <a:tcPr/>
+                </a:tc>
+                <a:tc>
+                  <a:txBody>
+                    <a:bodyPr/>
+                    <a:lstStyle/>
+                    <a:p>
+                      <a:pPr algn="ctr"/>
+                      <a:r>
+                        <a:rPr lang="en-US" sz="1400" dirty="0"/>
+                        <a:t>52,000</a:t>
+                      </a:r>
+                    </a:p>
+                  </a:txBody>
+                  <a:tcPr/>
+                </a:tc>
+                <a:tc>
+                  <a:txBody>
+                    <a:bodyPr/>
+                    <a:lstStyle/>
+                    <a:p>
+                      <a:pPr algn="ctr"/>
+                      <a:r>
+                        <a:rPr lang="en-US" sz="1400" dirty="0"/>
+                        <a:t>55,000</a:t>
+                      </a:r>
+                    </a:p>
+                  </a:txBody>
+                  <a:tcPr/>
+                </a:tc>
+              </a:tr>
+            </a:tbl>
+          </a:graphicData>
+        </a:graphic>
+      </p:graphicFrame>
+    </p:spTree>
+  </p:cSld>
+</p:sld>
+</file>
+
+<file path=ppt/slides/slide3.xml><?xml version="1.0" encoding="utf-8"?>
+<p:sld xmlns:p="http://schemas.openxmlformats.org/presentationml/2006/main">
+  <p:cSld>
+    <p:spTree>
+      <p:nvGrpSpPr>
+        <p:cNvPr id="1" name=""/>
+        <p:cNvGrpSpPr/>
+        <p:nvPr/>
+      </p:nvGrpSpPr>
+      <p:grpSpPr/>
+      <p:sp>
+        <p:nvSpPr>
+          <p:cNvPr id="100000" name="TextBox 1"/>
+          <p:cNvSpPr txBox="1"/>
+          <p:nvPr/>
+        </p:nvSpPr>
+        <p:spPr>
+          <a:xfrm xmlns:a="http://schemas.openxmlformats.org/drawingml/2006/main">
+            <a:off x="500000" y="200000"/>
+            <a:ext cx="11192000" cy="600000"/>
+          </a:xfrm>
+          <a:prstGeom xmlns:a="http://schemas.openxmlformats.org/drawingml/2006/main" prst="rect">
+            <a:avLst/>
+          </a:prstGeom>
+        </p:spPr>
+        <p:txBody>
+          <a:bodyPr xmlns:a="http://schemas.openxmlformats.org/drawingml/2006/main"/>
+          <a:lstStyle xmlns:a="http://schemas.openxmlformats.org/drawingml/2006/main"/>
+          <a:p xmlns:a="http://schemas.openxmlformats.org/drawingml/2006/main">
+            <a:r>
+              <a:rPr lang="en-US" sz="2800" b="1"/>
+              <a:t>Annual Sales Share by Department</a:t>
+            </a:r>
+          </a:p>
+        </p:txBody>
+      </p:sp>
+      <p:sp>
+        <p:nvSpPr>
+          <p:cNvPr id="100001" name="TextBox 2"/>
+          <p:cNvSpPr txBox="1"/>
+          <p:nvPr/>
+        </p:nvSpPr>
+        <p:spPr>
+          <a:xfrm xmlns:a="http://schemas.openxmlformats.org/drawingml/2006/main">
+            <a:off x="1000000" y="1200000"/>
+            <a:ext cx="10000000" cy="500000"/>
+          </a:xfrm>
+          <a:prstGeom xmlns:a="http://schemas.openxmlformats.org/drawingml/2006/main" prst="rect">
+            <a:avLst/>
+          </a:prstGeom>
+        </p:spPr>
+        <p:txBody>
+          <a:bodyPr xmlns:a="http://schemas.openxmlformats.org/drawingml/2006/main"/>
+          <a:lstStyle xmlns:a="http://schemas.openxmlformats.org/drawingml/2006/main"/>
+          <a:p xmlns:a="http://schemas.openxmlformats.org/drawingml/2006/main">
+            <a:r>
+              <a:rPr lang="en-US"/>
+              <a:t>Engineering 683,000 (24.4%)</a:t>
+            </a:r>
+          </a:p>
+        </p:txBody>
+      </p:sp>
+      <p:sp>
+        <p:nvSpPr>
+          <p:cNvPr id="100002" name="TextBox 3"/>
+          <p:cNvSpPr txBox="1"/>
+          <p:nvPr/>
+        </p:nvSpPr>
+        <p:spPr>
+          <a:xfrm xmlns:a="http://schemas.openxmlformats.org/drawingml/2006/main">
+            <a:off x="1000000" y="1900000"/>
+            <a:ext cx="10000000" cy="500000"/>
+          </a:xfrm>
+          <a:prstGeom xmlns:a="http://schemas.openxmlformats.org/drawingml/2006/main" prst="rect">
+            <a:avLst/>
+          </a:prstGeom>
+        </p:spPr>
+        <p:txBody>
+          <a:bodyPr xmlns:a="http://schemas.openxmlformats.org/drawingml/2006/main"/>
+          <a:lstStyle xmlns:a="http://schemas.openxmlformats.org/drawingml/2006/main"/>
+          <a:p xmlns:a="http://schemas.openxmlformats.org/drawingml/2006/main">
+            <a:r>
+              <a:rPr lang="en-US"/>
+              <a:t>Marketing 510,000 (18.2%)</a:t>
+            </a:r>
+          </a:p>
+        </p:txBody>
+      </p:sp>
+      <p:sp>
+        <p:nvSpPr>
+          <p:cNvPr id="100003" name="TextBox 4"/>
+          <p:cNvSpPr txBox="1"/>
+          <p:nvPr/>
+        </p:nvSpPr>
+        <p:spPr>
+          <a:xfrm xmlns:a="http://schemas.openxmlformats.org/drawingml/2006/main">
+            <a:off x="1000000" y="2600000"/>
+            <a:ext cx="10000000" cy="500000"/>
+          </a:xfrm>
+          <a:prstGeom xmlns:a="http://schemas.openxmlformats.org/drawingml/2006/main" prst="rect">
+            <a:avLst/>
+          </a:prstGeom>
+        </p:spPr>
+        <p:txBody>
+          <a:bodyPr xmlns:a="http://schemas.openxmlformats.org/drawingml/2006/main"/>
+          <a:lstStyle xmlns:a="http://schemas.openxmlformats.org/drawingml/2006/main"/>
+          <a:p xmlns:a="http://schemas.openxmlformats.org/drawingml/2006/main">
+            <a:r>
+              <a:rPr lang="en-US"/>
+              <a:t>Operations 385,000 (13.7%)</a:t>
+            </a:r>
+          </a:p>
+        </p:txBody>
+      </p:sp>
+      <p:sp>
+        <p:nvSpPr>
+          <p:cNvPr id="100004" name="TextBox 5"/>
+          <p:cNvSpPr txBox="1"/>
+          <p:nvPr/>
+        </p:nvSpPr>
+        <p:spPr>
+          <a:xfrm xmlns:a="http://schemas.openxmlformats.org/drawingml/2006/main">
+            <a:off x="1000000" y="3300000"/>
+            <a:ext cx="10000000" cy="500000"/>
+          </a:xfrm>
+          <a:prstGeom xmlns:a="http://schemas.openxmlformats.org/drawingml/2006/main" prst="rect">
+            <a:avLst/>
+          </a:prstGeom>
+        </p:spPr>
+        <p:txBody>
+          <a:bodyPr xmlns:a="http://schemas.openxmlformats.org/drawingml/2006/main"/>
+          <a:lstStyle xmlns:a="http://schemas.openxmlformats.org/drawingml/2006/main"/>
+          <a:p xmlns:a="http://schemas.openxmlformats.org/drawingml/2006/main">
+            <a:r>
+              <a:rPr lang="en-US"/>
+              <a:t>Sales 1,171,000 (41.8%)</a:t>
+            </a:r>
+          </a:p>
+        </p:txBody>
+      </p:sp>
+      <p:sp>
+        <p:nvSpPr>
+          <p:cNvPr id="100005" name="TextBox 6"/>
+          <p:cNvSpPr txBox="1"/>
+          <p:nvPr/>
+        </p:nvSpPr>
+        <p:spPr>
+          <a:xfrm xmlns:a="http://schemas.openxmlformats.org/drawingml/2006/main">
+            <a:off x="1000000" y="4000000"/>
+            <a:ext cx="10000000" cy="500000"/>
+          </a:xfrm>
+          <a:prstGeom xmlns:a="http://schemas.openxmlformats.org/drawingml/2006/main" prst="rect">
+            <a:avLst/>
+          </a:prstGeom>
+        </p:spPr>
+        <p:txBody>
+          <a:bodyPr xmlns:a="http://schemas.openxmlformats.org/drawingml/2006/main"/>
+          <a:lstStyle xmlns:a="http://schemas.openxmlformats.org/drawingml/2006/main"/>
+          <a:p xmlns:a="http://schemas.openxmlformats.org/drawingml/2006/main">
+            <a:r>
+              <a:rPr lang="en-US"/>
+              <a:t>HR 200,000 (7.1%)</a:t>
+            </a:r>
+          </a:p>
+        </p:txBody>
+      </p:sp>
+    </p:spTree>
+  </p:cSld>
+</p:sld>
 </file>
 
 <file path=ppt/theme/theme1.xml><?xml version="1.0" encoding="utf-8"?>

</xml_diff>